<commit_message>
Match the photo board slide to the full-screen board and auto-created word cards
</commit_message>
<xml_diff>
--- a/deck/Nyambung-Pitch-Deck.pptx
+++ b/deck/Nyambung-Pitch-Deck.pptx
@@ -33801,7 +33801,7 @@
                 <a:ea typeface="Calibri" pitchFamily="34" charset="-122"/>
                 <a:cs typeface="Calibri" pitchFamily="34" charset="-120"/>
               </a:rPr>
-              <a:t>Patenaude, McNaughton &amp; Liang (2024), Journal of Special Education Technology 40(1) · PERUBAHAN.md entri 22 dan 23 · server/app/routes/scene_ai.py. Ilustrasi mengikuti layar aplikasi.</a:t>
+              <a:t>Patenaude, McNaughton &amp; Liang (2024), Journal of Special Education Technology 40(1) · PERUBAHAN.md entri 22, 23, 26, 27 · server/app/routes/scene_ai.py. Ilustrasi mengikuti layar aplikasi.</a:t>
             </a:r>
             <a:endParaRPr lang="en-US" sz="850" dirty="0"/>
           </a:p>
@@ -33934,11 +33934,11 @@
         <p:spPr>
           <a:xfrm>
             <a:off x="722376" y="2340864"/>
-            <a:ext cx="2167128" cy="2011680"/>
+            <a:ext cx="2167128" cy="2331720"/>
           </a:xfrm>
           <a:prstGeom prst="roundRect">
             <a:avLst>
-              <a:gd name="adj" fmla="val 3636"/>
+              <a:gd name="adj" fmla="val 3376"/>
             </a:avLst>
           </a:prstGeom>
           <a:solidFill>
@@ -34240,12 +34240,102 @@
         </p:nvSpPr>
         <p:spPr>
           <a:xfrm>
-            <a:off x="722376" y="4462272"/>
-            <a:ext cx="691896" cy="512064"/>
+            <a:off x="722376" y="4782312"/>
+            <a:ext cx="691896" cy="658368"/>
           </a:xfrm>
           <a:prstGeom prst="roundRect">
             <a:avLst>
-              <a:gd name="adj" fmla="val 10714"/>
+              <a:gd name="adj" fmla="val 8333"/>
+            </a:avLst>
+          </a:prstGeom>
+          <a:solidFill>
+            <a:srgbClr val="E8F6F5"/>
+          </a:solidFill>
+          <a:ln w="12700">
+            <a:solidFill>
+              <a:srgbClr val="C7C7D2"/>
+            </a:solidFill>
+            <a:prstDash val="solid"/>
+          </a:ln>
+        </p:spPr>
+      </p:sp>
+      <p:pic>
+        <p:nvPicPr>
+          <p:cNvPr id="26" name="Image 1" descr="C:\Users\mikae\OneDrive\Documents\Lomba\IFEST\Nyambung\assets\symbols\png\lagi.png">    </p:cNvPr>
+          <p:cNvPicPr>
+            <a:picLocks noChangeAspect="1"/>
+          </p:cNvPicPr>
+          <p:nvPr/>
+        </p:nvPicPr>
+        <p:blipFill>
+          <a:blip r:embed="rId2"/>
+          <a:stretch>
+            <a:fillRect/>
+          </a:stretch>
+        </p:blipFill>
+        <p:spPr>
+          <a:xfrm>
+            <a:off x="883981" y="4834981"/>
+            <a:ext cx="368686" cy="368686"/>
+          </a:xfrm>
+          <a:prstGeom prst="rect">
+            <a:avLst/>
+          </a:prstGeom>
+        </p:spPr>
+      </p:pic>
+      <p:sp>
+        <p:nvSpPr>
+          <p:cNvPr id="27" name="Text 22"/>
+          <p:cNvSpPr/>
+          <p:nvPr/>
+        </p:nvSpPr>
+        <p:spPr>
+          <a:xfrm>
+            <a:off x="722376" y="5216835"/>
+            <a:ext cx="691896" cy="197510"/>
+          </a:xfrm>
+          <a:prstGeom prst="rect">
+            <a:avLst/>
+          </a:prstGeom>
+          <a:noFill/>
+          <a:ln/>
+        </p:spPr>
+        <p:txBody>
+          <a:bodyPr wrap="square" lIns="0" tIns="0" rIns="0" bIns="0" rtlCol="0" anchor="ctr"/>
+          <a:lstStyle/>
+          <a:p>
+            <a:pPr algn="ctr" indent="0" marL="0">
+              <a:buNone/>
+            </a:pPr>
+            <a:r>
+              <a:rPr lang="en-US" sz="750" b="1" dirty="0">
+                <a:solidFill>
+                  <a:srgbClr val="172C2A"/>
+                </a:solidFill>
+                <a:latin typeface="Calibri" pitchFamily="34" charset="0"/>
+                <a:ea typeface="Calibri" pitchFamily="34" charset="-122"/>
+                <a:cs typeface="Calibri" pitchFamily="34" charset="-120"/>
+              </a:rPr>
+              <a:t>LAGI</a:t>
+            </a:r>
+            <a:endParaRPr lang="en-US" sz="750" dirty="0"/>
+          </a:p>
+        </p:txBody>
+      </p:sp>
+      <p:sp>
+        <p:nvSpPr>
+          <p:cNvPr id="28" name="Shape 23"/>
+          <p:cNvSpPr/>
+          <p:nvPr/>
+        </p:nvSpPr>
+        <p:spPr>
+          <a:xfrm>
+            <a:off x="1459992" y="4782312"/>
+            <a:ext cx="691896" cy="658368"/>
+          </a:xfrm>
+          <a:prstGeom prst="roundRect">
+            <a:avLst>
+              <a:gd name="adj" fmla="val 8333"/>
             </a:avLst>
           </a:prstGeom>
           <a:solidFill>
@@ -34261,22 +34351,22 @@
       </p:sp>
       <p:pic>
         <p:nvPicPr>
-          <p:cNvPr id="26" name="Image 1" descr="C:\Users\mikae\OneDrive\Documents\Lomba\IFEST\Nyambung\assets\symbols\png\mau.png">    </p:cNvPr>
+          <p:cNvPr id="29" name="Image 2" descr="C:\Users\mikae\OneDrive\Documents\Lomba\IFEST\Nyambung\assets\symbols\png\makan.png">    </p:cNvPr>
           <p:cNvPicPr>
             <a:picLocks noChangeAspect="1"/>
           </p:cNvPicPr>
           <p:nvPr/>
         </p:nvPicPr>
         <p:blipFill>
-          <a:blip r:embed="rId2"/>
+          <a:blip r:embed="rId3"/>
           <a:stretch>
             <a:fillRect/>
           </a:stretch>
         </p:blipFill>
         <p:spPr>
           <a:xfrm>
-            <a:off x="924946" y="4503237"/>
-            <a:ext cx="286756" cy="286756"/>
+            <a:off x="1621597" y="4834981"/>
+            <a:ext cx="368686" cy="368686"/>
           </a:xfrm>
           <a:prstGeom prst="rect">
             <a:avLst/>
@@ -34285,14 +34375,14 @@
       </p:pic>
       <p:sp>
         <p:nvSpPr>
-          <p:cNvPr id="27" name="Text 22"/>
-          <p:cNvSpPr/>
-          <p:nvPr/>
-        </p:nvSpPr>
-        <p:spPr>
-          <a:xfrm>
-            <a:off x="722376" y="4800234"/>
-            <a:ext cx="691896" cy="153619"/>
+          <p:cNvPr id="30" name="Text 24"/>
+          <p:cNvSpPr/>
+          <p:nvPr/>
+        </p:nvSpPr>
+        <p:spPr>
+          <a:xfrm>
+            <a:off x="1459992" y="5216835"/>
+            <a:ext cx="691896" cy="197510"/>
           </a:xfrm>
           <a:prstGeom prst="rect">
             <a:avLst/>
@@ -34316,7 +34406,7 @@
                 <a:ea typeface="Calibri" pitchFamily="34" charset="-122"/>
                 <a:cs typeface="Calibri" pitchFamily="34" charset="-120"/>
               </a:rPr>
-              <a:t>MAU</a:t>
+              <a:t>MAKAN</a:t>
             </a:r>
             <a:endParaRPr lang="en-US" sz="750" dirty="0"/>
           </a:p>
@@ -34324,18 +34414,18 @@
       </p:sp>
       <p:sp>
         <p:nvSpPr>
-          <p:cNvPr id="28" name="Shape 23"/>
-          <p:cNvSpPr/>
-          <p:nvPr/>
-        </p:nvSpPr>
-        <p:spPr>
-          <a:xfrm>
-            <a:off x="1459992" y="4462272"/>
-            <a:ext cx="691896" cy="512064"/>
+          <p:cNvPr id="31" name="Shape 25"/>
+          <p:cNvSpPr/>
+          <p:nvPr/>
+        </p:nvSpPr>
+        <p:spPr>
+          <a:xfrm>
+            <a:off x="2197608" y="4782312"/>
+            <a:ext cx="691896" cy="658368"/>
           </a:xfrm>
           <a:prstGeom prst="roundRect">
             <a:avLst>
-              <a:gd name="adj" fmla="val 10714"/>
+              <a:gd name="adj" fmla="val 8333"/>
             </a:avLst>
           </a:prstGeom>
           <a:solidFill>
@@ -34351,97 +34441,7 @@
       </p:sp>
       <p:pic>
         <p:nvPicPr>
-          <p:cNvPr id="29" name="Image 2" descr="C:\Users\mikae\OneDrive\Documents\Lomba\IFEST\Nyambung\assets\symbols\custom\berhenti.png">    </p:cNvPr>
-          <p:cNvPicPr>
-            <a:picLocks noChangeAspect="1"/>
-          </p:cNvPicPr>
-          <p:nvPr/>
-        </p:nvPicPr>
-        <p:blipFill>
-          <a:blip r:embed="rId3"/>
-          <a:stretch>
-            <a:fillRect/>
-          </a:stretch>
-        </p:blipFill>
-        <p:spPr>
-          <a:xfrm>
-            <a:off x="1662562" y="4503237"/>
-            <a:ext cx="286756" cy="286756"/>
-          </a:xfrm>
-          <a:prstGeom prst="rect">
-            <a:avLst/>
-          </a:prstGeom>
-        </p:spPr>
-      </p:pic>
-      <p:sp>
-        <p:nvSpPr>
-          <p:cNvPr id="30" name="Text 24"/>
-          <p:cNvSpPr/>
-          <p:nvPr/>
-        </p:nvSpPr>
-        <p:spPr>
-          <a:xfrm>
-            <a:off x="1459992" y="4800234"/>
-            <a:ext cx="691896" cy="153619"/>
-          </a:xfrm>
-          <a:prstGeom prst="rect">
-            <a:avLst/>
-          </a:prstGeom>
-          <a:noFill/>
-          <a:ln/>
-        </p:spPr>
-        <p:txBody>
-          <a:bodyPr wrap="square" lIns="0" tIns="0" rIns="0" bIns="0" rtlCol="0" anchor="ctr"/>
-          <a:lstStyle/>
-          <a:p>
-            <a:pPr algn="ctr" indent="0" marL="0">
-              <a:buNone/>
-            </a:pPr>
-            <a:r>
-              <a:rPr lang="en-US" sz="750" b="1" dirty="0">
-                <a:solidFill>
-                  <a:srgbClr val="2A7445"/>
-                </a:solidFill>
-                <a:latin typeface="Calibri" pitchFamily="34" charset="0"/>
-                <a:ea typeface="Calibri" pitchFamily="34" charset="-122"/>
-                <a:cs typeface="Calibri" pitchFamily="34" charset="-120"/>
-              </a:rPr>
-              <a:t>BERHENTI</a:t>
-            </a:r>
-            <a:endParaRPr lang="en-US" sz="750" dirty="0"/>
-          </a:p>
-        </p:txBody>
-      </p:sp>
-      <p:sp>
-        <p:nvSpPr>
-          <p:cNvPr id="31" name="Shape 25"/>
-          <p:cNvSpPr/>
-          <p:nvPr/>
-        </p:nvSpPr>
-        <p:spPr>
-          <a:xfrm>
-            <a:off x="2197608" y="4462272"/>
-            <a:ext cx="691896" cy="512064"/>
-          </a:xfrm>
-          <a:prstGeom prst="roundRect">
-            <a:avLst>
-              <a:gd name="adj" fmla="val 10714"/>
-            </a:avLst>
-          </a:prstGeom>
-          <a:solidFill>
-            <a:srgbClr val="E1F4E7"/>
-          </a:solidFill>
-          <a:ln w="12700">
-            <a:solidFill>
-              <a:srgbClr val="6FC08F"/>
-            </a:solidFill>
-            <a:prstDash val="solid"/>
-          </a:ln>
-        </p:spPr>
-      </p:sp>
-      <p:pic>
-        <p:nvPicPr>
-          <p:cNvPr id="32" name="Image 3" descr="C:\Users\mikae\OneDrive\Documents\Lomba\IFEST\Nyambung\assets\symbols\png\bantu.png">    </p:cNvPr>
+          <p:cNvPr id="32" name="Image 3" descr="C:\Users\mikae\OneDrive\Documents\Lomba\IFEST\Nyambung\assets\symbols\png\minum.png">    </p:cNvPr>
           <p:cNvPicPr>
             <a:picLocks noChangeAspect="1"/>
           </p:cNvPicPr>
@@ -34455,8 +34455,8 @@
         </p:blipFill>
         <p:spPr>
           <a:xfrm>
-            <a:off x="2400178" y="4503237"/>
-            <a:ext cx="286756" cy="286756"/>
+            <a:off x="2359213" y="4834981"/>
+            <a:ext cx="368686" cy="368686"/>
           </a:xfrm>
           <a:prstGeom prst="rect">
             <a:avLst/>
@@ -34471,8 +34471,8 @@
         </p:nvSpPr>
         <p:spPr>
           <a:xfrm>
-            <a:off x="2197608" y="4800234"/>
-            <a:ext cx="691896" cy="153619"/>
+            <a:off x="2197608" y="5216835"/>
+            <a:ext cx="691896" cy="197510"/>
           </a:xfrm>
           <a:prstGeom prst="rect">
             <a:avLst/>
@@ -34496,7 +34496,7 @@
                 <a:ea typeface="Calibri" pitchFamily="34" charset="-122"/>
                 <a:cs typeface="Calibri" pitchFamily="34" charset="-120"/>
               </a:rPr>
-              <a:t>BANTU</a:t>
+              <a:t>MINUM</a:t>
             </a:r>
             <a:endParaRPr lang="en-US" sz="750" dirty="0"/>
           </a:p>
@@ -34504,65 +34504,14 @@
       </p:sp>
       <p:sp>
         <p:nvSpPr>
-          <p:cNvPr id="34" name="Shape 27"/>
-          <p:cNvSpPr/>
-          <p:nvPr/>
-        </p:nvSpPr>
-        <p:spPr>
-          <a:xfrm>
-            <a:off x="722376" y="5020056"/>
-            <a:ext cx="691896" cy="512064"/>
-          </a:xfrm>
-          <a:prstGeom prst="roundRect">
-            <a:avLst>
-              <a:gd name="adj" fmla="val 10714"/>
-            </a:avLst>
-          </a:prstGeom>
-          <a:solidFill>
-            <a:srgbClr val="E8F6F5"/>
-          </a:solidFill>
-          <a:ln w="12700">
-            <a:solidFill>
-              <a:srgbClr val="C7C7D2"/>
-            </a:solidFill>
-            <a:prstDash val="solid"/>
-          </a:ln>
-        </p:spPr>
-      </p:sp>
-      <p:pic>
-        <p:nvPicPr>
-          <p:cNvPr id="35" name="Image 4" descr="C:\Users\mikae\OneDrive\Documents\Lomba\IFEST\Nyambung\assets\symbols\png\tidak.png">    </p:cNvPr>
-          <p:cNvPicPr>
-            <a:picLocks noChangeAspect="1"/>
-          </p:cNvPicPr>
-          <p:nvPr/>
-        </p:nvPicPr>
-        <p:blipFill>
-          <a:blip r:embed="rId5"/>
-          <a:stretch>
-            <a:fillRect/>
-          </a:stretch>
-        </p:blipFill>
-        <p:spPr>
-          <a:xfrm>
-            <a:off x="924946" y="5061021"/>
-            <a:ext cx="286756" cy="286756"/>
-          </a:xfrm>
-          <a:prstGeom prst="rect">
-            <a:avLst/>
-          </a:prstGeom>
-        </p:spPr>
-      </p:pic>
-      <p:sp>
-        <p:nvSpPr>
-          <p:cNvPr id="36" name="Text 28"/>
-          <p:cNvSpPr/>
-          <p:nvPr/>
-        </p:nvSpPr>
-        <p:spPr>
-          <a:xfrm>
-            <a:off x="722376" y="5358018"/>
-            <a:ext cx="691896" cy="153619"/>
+          <p:cNvPr id="34" name="Text 27"/>
+          <p:cNvSpPr/>
+          <p:nvPr/>
+        </p:nvSpPr>
+        <p:spPr>
+          <a:xfrm>
+            <a:off x="722376" y="5513832"/>
+            <a:ext cx="2167128" cy="182880"/>
           </a:xfrm>
           <a:prstGeom prst="rect">
             <a:avLst/>
@@ -34578,225 +34527,6 @@
               <a:buNone/>
             </a:pPr>
             <a:r>
-              <a:rPr lang="en-US" sz="750" b="1" dirty="0">
-                <a:solidFill>
-                  <a:srgbClr val="172C2A"/>
-                </a:solidFill>
-                <a:latin typeface="Calibri" pitchFamily="34" charset="0"/>
-                <a:ea typeface="Calibri" pitchFamily="34" charset="-122"/>
-                <a:cs typeface="Calibri" pitchFamily="34" charset="-120"/>
-              </a:rPr>
-              <a:t>TIDAK</a:t>
-            </a:r>
-            <a:endParaRPr lang="en-US" sz="750" dirty="0"/>
-          </a:p>
-        </p:txBody>
-      </p:sp>
-      <p:sp>
-        <p:nvSpPr>
-          <p:cNvPr id="37" name="Shape 29"/>
-          <p:cNvSpPr/>
-          <p:nvPr/>
-        </p:nvSpPr>
-        <p:spPr>
-          <a:xfrm>
-            <a:off x="1459992" y="5020056"/>
-            <a:ext cx="691896" cy="512064"/>
-          </a:xfrm>
-          <a:prstGeom prst="roundRect">
-            <a:avLst>
-              <a:gd name="adj" fmla="val 10714"/>
-            </a:avLst>
-          </a:prstGeom>
-          <a:solidFill>
-            <a:srgbClr val="E8F6F5"/>
-          </a:solidFill>
-          <a:ln w="12700">
-            <a:solidFill>
-              <a:srgbClr val="C7C7D2"/>
-            </a:solidFill>
-            <a:prstDash val="solid"/>
-          </a:ln>
-        </p:spPr>
-      </p:sp>
-      <p:pic>
-        <p:nvPicPr>
-          <p:cNvPr id="38" name="Image 5" descr="C:\Users\mikae\OneDrive\Documents\Lomba\IFEST\Nyambung\assets\symbols\png\selesai.png">    </p:cNvPr>
-          <p:cNvPicPr>
-            <a:picLocks noChangeAspect="1"/>
-          </p:cNvPicPr>
-          <p:nvPr/>
-        </p:nvPicPr>
-        <p:blipFill>
-          <a:blip r:embed="rId6"/>
-          <a:stretch>
-            <a:fillRect/>
-          </a:stretch>
-        </p:blipFill>
-        <p:spPr>
-          <a:xfrm>
-            <a:off x="1662562" y="5061021"/>
-            <a:ext cx="286756" cy="286756"/>
-          </a:xfrm>
-          <a:prstGeom prst="rect">
-            <a:avLst/>
-          </a:prstGeom>
-        </p:spPr>
-      </p:pic>
-      <p:sp>
-        <p:nvSpPr>
-          <p:cNvPr id="39" name="Text 30"/>
-          <p:cNvSpPr/>
-          <p:nvPr/>
-        </p:nvSpPr>
-        <p:spPr>
-          <a:xfrm>
-            <a:off x="1459992" y="5358018"/>
-            <a:ext cx="691896" cy="153619"/>
-          </a:xfrm>
-          <a:prstGeom prst="rect">
-            <a:avLst/>
-          </a:prstGeom>
-          <a:noFill/>
-          <a:ln/>
-        </p:spPr>
-        <p:txBody>
-          <a:bodyPr wrap="square" lIns="0" tIns="0" rIns="0" bIns="0" rtlCol="0" anchor="ctr"/>
-          <a:lstStyle/>
-          <a:p>
-            <a:pPr algn="ctr" indent="0" marL="0">
-              <a:buNone/>
-            </a:pPr>
-            <a:r>
-              <a:rPr lang="en-US" sz="750" b="1" dirty="0">
-                <a:solidFill>
-                  <a:srgbClr val="172C2A"/>
-                </a:solidFill>
-                <a:latin typeface="Calibri" pitchFamily="34" charset="0"/>
-                <a:ea typeface="Calibri" pitchFamily="34" charset="-122"/>
-                <a:cs typeface="Calibri" pitchFamily="34" charset="-120"/>
-              </a:rPr>
-              <a:t>SELESAI</a:t>
-            </a:r>
-            <a:endParaRPr lang="en-US" sz="750" dirty="0"/>
-          </a:p>
-        </p:txBody>
-      </p:sp>
-      <p:sp>
-        <p:nvSpPr>
-          <p:cNvPr id="40" name="Shape 31"/>
-          <p:cNvSpPr/>
-          <p:nvPr/>
-        </p:nvSpPr>
-        <p:spPr>
-          <a:xfrm>
-            <a:off x="2197608" y="5020056"/>
-            <a:ext cx="691896" cy="512064"/>
-          </a:xfrm>
-          <a:prstGeom prst="roundRect">
-            <a:avLst>
-              <a:gd name="adj" fmla="val 10714"/>
-            </a:avLst>
-          </a:prstGeom>
-          <a:solidFill>
-            <a:srgbClr val="DEF3FC"/>
-          </a:solidFill>
-          <a:ln w="12700">
-            <a:solidFill>
-              <a:srgbClr val="6FC3EA"/>
-            </a:solidFill>
-            <a:prstDash val="solid"/>
-          </a:ln>
-        </p:spPr>
-      </p:sp>
-      <p:pic>
-        <p:nvPicPr>
-          <p:cNvPr id="41" name="Image 6" descr="C:\Users\mikae\OneDrive\Documents\Lomba\IFEST\Nyambung\assets\symbols\png\sakit.png">    </p:cNvPr>
-          <p:cNvPicPr>
-            <a:picLocks noChangeAspect="1"/>
-          </p:cNvPicPr>
-          <p:nvPr/>
-        </p:nvPicPr>
-        <p:blipFill>
-          <a:blip r:embed="rId7"/>
-          <a:stretch>
-            <a:fillRect/>
-          </a:stretch>
-        </p:blipFill>
-        <p:spPr>
-          <a:xfrm>
-            <a:off x="2400178" y="5061021"/>
-            <a:ext cx="286756" cy="286756"/>
-          </a:xfrm>
-          <a:prstGeom prst="rect">
-            <a:avLst/>
-          </a:prstGeom>
-        </p:spPr>
-      </p:pic>
-      <p:sp>
-        <p:nvSpPr>
-          <p:cNvPr id="42" name="Text 32"/>
-          <p:cNvSpPr/>
-          <p:nvPr/>
-        </p:nvSpPr>
-        <p:spPr>
-          <a:xfrm>
-            <a:off x="2197608" y="5358018"/>
-            <a:ext cx="691896" cy="153619"/>
-          </a:xfrm>
-          <a:prstGeom prst="rect">
-            <a:avLst/>
-          </a:prstGeom>
-          <a:noFill/>
-          <a:ln/>
-        </p:spPr>
-        <p:txBody>
-          <a:bodyPr wrap="square" lIns="0" tIns="0" rIns="0" bIns="0" rtlCol="0" anchor="ctr"/>
-          <a:lstStyle/>
-          <a:p>
-            <a:pPr algn="ctr" indent="0" marL="0">
-              <a:buNone/>
-            </a:pPr>
-            <a:r>
-              <a:rPr lang="en-US" sz="750" b="1" dirty="0">
-                <a:solidFill>
-                  <a:srgbClr val="1D6F94"/>
-                </a:solidFill>
-                <a:latin typeface="Calibri" pitchFamily="34" charset="0"/>
-                <a:ea typeface="Calibri" pitchFamily="34" charset="-122"/>
-                <a:cs typeface="Calibri" pitchFamily="34" charset="-120"/>
-              </a:rPr>
-              <a:t>SAKIT</a:t>
-            </a:r>
-            <a:endParaRPr lang="en-US" sz="750" dirty="0"/>
-          </a:p>
-        </p:txBody>
-      </p:sp>
-      <p:sp>
-        <p:nvSpPr>
-          <p:cNvPr id="43" name="Text 33"/>
-          <p:cNvSpPr/>
-          <p:nvPr/>
-        </p:nvSpPr>
-        <p:spPr>
-          <a:xfrm>
-            <a:off x="722376" y="5596128"/>
-            <a:ext cx="2167128" cy="182880"/>
-          </a:xfrm>
-          <a:prstGeom prst="rect">
-            <a:avLst/>
-          </a:prstGeom>
-          <a:noFill/>
-          <a:ln/>
-        </p:spPr>
-        <p:txBody>
-          <a:bodyPr wrap="square" lIns="0" tIns="0" rIns="0" bIns="0" rtlCol="0" anchor="ctr"/>
-          <a:lstStyle/>
-          <a:p>
-            <a:pPr algn="ctr" indent="0" marL="0">
-              <a:buNone/>
-            </a:pPr>
-            <a:r>
               <a:rPr lang="en-US" sz="700" dirty="0">
                 <a:solidFill>
                   <a:srgbClr val="52706D"/>
@@ -34805,7 +34535,7 @@
                 <a:ea typeface="Calibri" pitchFamily="34" charset="-122"/>
                 <a:cs typeface="Calibri" pitchFamily="34" charset="-120"/>
               </a:rPr>
-              <a:t>Enam kata inti tetap di posisi yang sama</a:t>
+              <a:t>Kata area dalam grid tetap; kata inti tetap di tab INTI</a:t>
             </a:r>
             <a:endParaRPr lang="en-US" sz="700" dirty="0"/>
           </a:p>
@@ -34813,7 +34543,7 @@
       </p:sp>
       <p:sp>
         <p:nvSpPr>
-          <p:cNvPr id="44" name="Text 34"/>
+          <p:cNvPr id="35" name="Text 28"/>
           <p:cNvSpPr/>
           <p:nvPr/>
         </p:nvSpPr>
@@ -34902,7 +34632,7 @@
       </p:sp>
       <p:sp>
         <p:nvSpPr>
-          <p:cNvPr id="45" name="Shape 35"/>
+          <p:cNvPr id="36" name="Shape 29"/>
           <p:cNvSpPr/>
           <p:nvPr/>
         </p:nvSpPr>
@@ -34929,7 +34659,7 @@
       </p:sp>
       <p:sp>
         <p:nvSpPr>
-          <p:cNvPr id="46" name="Shape 36"/>
+          <p:cNvPr id="37" name="Shape 30"/>
           <p:cNvSpPr/>
           <p:nvPr/>
         </p:nvSpPr>
@@ -34954,14 +34684,14 @@
       </p:sp>
       <p:pic>
         <p:nvPicPr>
-          <p:cNvPr id="47" name="Image 7" descr="preencoded.png">    </p:cNvPr>
+          <p:cNvPr id="38" name="Image 4" descr="preencoded.png">    </p:cNvPr>
           <p:cNvPicPr>
             <a:picLocks noChangeAspect="1"/>
           </p:cNvPicPr>
           <p:nvPr/>
         </p:nvPicPr>
         <p:blipFill>
-          <a:blip r:embed="rId8"/>
+          <a:blip r:embed="rId5"/>
           <a:stretch>
             <a:fillRect/>
           </a:stretch>
@@ -34978,7 +34708,7 @@
       </p:pic>
       <p:sp>
         <p:nvSpPr>
-          <p:cNvPr id="48" name="Text 37"/>
+          <p:cNvPr id="39" name="Text 31"/>
           <p:cNvSpPr/>
           <p:nvPr/>
         </p:nvSpPr>
@@ -35017,7 +34747,7 @@
       </p:sp>
       <p:sp>
         <p:nvSpPr>
-          <p:cNvPr id="49" name="Text 38"/>
+          <p:cNvPr id="40" name="Text 32"/>
           <p:cNvSpPr/>
           <p:nvPr/>
         </p:nvSpPr>
@@ -35056,7 +34786,7 @@
       </p:sp>
       <p:sp>
         <p:nvSpPr>
-          <p:cNvPr id="50" name="Text 39"/>
+          <p:cNvPr id="41" name="Text 33"/>
           <p:cNvSpPr/>
           <p:nvPr/>
         </p:nvSpPr>
@@ -35095,7 +34825,7 @@
       </p:sp>
       <p:sp>
         <p:nvSpPr>
-          <p:cNvPr id="51" name="Shape 40"/>
+          <p:cNvPr id="42" name="Shape 34"/>
           <p:cNvSpPr/>
           <p:nvPr/>
         </p:nvSpPr>
@@ -35122,7 +34852,7 @@
       </p:sp>
       <p:sp>
         <p:nvSpPr>
-          <p:cNvPr id="52" name="Shape 41"/>
+          <p:cNvPr id="43" name="Shape 35"/>
           <p:cNvSpPr/>
           <p:nvPr/>
         </p:nvSpPr>
@@ -35147,14 +34877,14 @@
       </p:sp>
       <p:pic>
         <p:nvPicPr>
-          <p:cNvPr id="53" name="Image 8" descr="preencoded.png">    </p:cNvPr>
+          <p:cNvPr id="44" name="Image 5" descr="preencoded.png">    </p:cNvPr>
           <p:cNvPicPr>
             <a:picLocks noChangeAspect="1"/>
           </p:cNvPicPr>
           <p:nvPr/>
         </p:nvPicPr>
         <p:blipFill>
-          <a:blip r:embed="rId9"/>
+          <a:blip r:embed="rId6"/>
           <a:stretch>
             <a:fillRect/>
           </a:stretch>
@@ -35171,7 +34901,7 @@
       </p:pic>
       <p:sp>
         <p:nvSpPr>
-          <p:cNvPr id="54" name="Text 42"/>
+          <p:cNvPr id="45" name="Text 36"/>
           <p:cNvSpPr/>
           <p:nvPr/>
         </p:nvSpPr>
@@ -35210,7 +34940,7 @@
       </p:sp>
       <p:sp>
         <p:nvSpPr>
-          <p:cNvPr id="55" name="Text 43"/>
+          <p:cNvPr id="46" name="Text 37"/>
           <p:cNvSpPr/>
           <p:nvPr/>
         </p:nvSpPr>
@@ -35249,7 +34979,7 @@
       </p:sp>
       <p:sp>
         <p:nvSpPr>
-          <p:cNvPr id="56" name="Text 44"/>
+          <p:cNvPr id="47" name="Text 38"/>
           <p:cNvSpPr/>
           <p:nvPr/>
         </p:nvSpPr>
@@ -35288,7 +35018,7 @@
       </p:sp>
       <p:sp>
         <p:nvSpPr>
-          <p:cNvPr id="57" name="Shape 45"/>
+          <p:cNvPr id="48" name="Shape 39"/>
           <p:cNvSpPr/>
           <p:nvPr/>
         </p:nvSpPr>
@@ -35315,7 +35045,7 @@
       </p:sp>
       <p:sp>
         <p:nvSpPr>
-          <p:cNvPr id="58" name="Shape 46"/>
+          <p:cNvPr id="49" name="Shape 40"/>
           <p:cNvSpPr/>
           <p:nvPr/>
         </p:nvSpPr>
@@ -35340,14 +35070,14 @@
       </p:sp>
       <p:pic>
         <p:nvPicPr>
-          <p:cNvPr id="59" name="Image 9" descr="preencoded.png">    </p:cNvPr>
+          <p:cNvPr id="50" name="Image 6" descr="preencoded.png">    </p:cNvPr>
           <p:cNvPicPr>
             <a:picLocks noChangeAspect="1"/>
           </p:cNvPicPr>
           <p:nvPr/>
         </p:nvPicPr>
         <p:blipFill>
-          <a:blip r:embed="rId10"/>
+          <a:blip r:embed="rId7"/>
           <a:stretch>
             <a:fillRect/>
           </a:stretch>
@@ -35364,7 +35094,7 @@
       </p:pic>
       <p:sp>
         <p:nvSpPr>
-          <p:cNvPr id="60" name="Text 47"/>
+          <p:cNvPr id="51" name="Text 41"/>
           <p:cNvSpPr/>
           <p:nvPr/>
         </p:nvSpPr>
@@ -35403,7 +35133,7 @@
       </p:sp>
       <p:sp>
         <p:nvSpPr>
-          <p:cNvPr id="61" name="Text 48"/>
+          <p:cNvPr id="52" name="Text 42"/>
           <p:cNvSpPr/>
           <p:nvPr/>
         </p:nvSpPr>
@@ -35442,7 +35172,7 @@
       </p:sp>
       <p:sp>
         <p:nvSpPr>
-          <p:cNvPr id="62" name="Text 49"/>
+          <p:cNvPr id="53" name="Text 43"/>
           <p:cNvSpPr/>
           <p:nvPr/>
         </p:nvSpPr>
@@ -35481,7 +35211,7 @@
       </p:sp>
       <p:sp>
         <p:nvSpPr>
-          <p:cNvPr id="63" name="Shape 50"/>
+          <p:cNvPr id="54" name="Shape 44"/>
           <p:cNvSpPr/>
           <p:nvPr/>
         </p:nvSpPr>
@@ -35508,7 +35238,7 @@
       </p:sp>
       <p:sp>
         <p:nvSpPr>
-          <p:cNvPr id="64" name="Shape 51"/>
+          <p:cNvPr id="55" name="Shape 45"/>
           <p:cNvSpPr/>
           <p:nvPr/>
         </p:nvSpPr>
@@ -35533,14 +35263,14 @@
       </p:sp>
       <p:pic>
         <p:nvPicPr>
-          <p:cNvPr id="65" name="Image 10" descr="preencoded.png">    </p:cNvPr>
+          <p:cNvPr id="56" name="Image 7" descr="preencoded.png">    </p:cNvPr>
           <p:cNvPicPr>
             <a:picLocks noChangeAspect="1"/>
           </p:cNvPicPr>
           <p:nvPr/>
         </p:nvPicPr>
         <p:blipFill>
-          <a:blip r:embed="rId11"/>
+          <a:blip r:embed="rId8"/>
           <a:stretch>
             <a:fillRect/>
           </a:stretch>
@@ -35557,7 +35287,7 @@
       </p:pic>
       <p:sp>
         <p:nvSpPr>
-          <p:cNvPr id="66" name="Text 52"/>
+          <p:cNvPr id="57" name="Text 46"/>
           <p:cNvSpPr/>
           <p:nvPr/>
         </p:nvSpPr>
@@ -35596,7 +35326,7 @@
       </p:sp>
       <p:sp>
         <p:nvSpPr>
-          <p:cNvPr id="67" name="Text 53"/>
+          <p:cNvPr id="58" name="Text 47"/>
           <p:cNvSpPr/>
           <p:nvPr/>
         </p:nvSpPr>
@@ -35627,7 +35357,7 @@
                 <a:ea typeface="Calibri" pitchFamily="34" charset="-122"/>
                 <a:cs typeface="Calibri" pitchFamily="34" charset="-120"/>
               </a:rPr>
-              <a:t>Keluarga memperbaiki; papan tersimpan dan dipakai luring.</a:t>
+              <a:t>Keluarga memperbaiki; benda tanpa kata dibuatkan kartu baru bersuara.</a:t>
             </a:r>
             <a:endParaRPr lang="en-US" sz="950" dirty="0"/>
           </a:p>
@@ -35635,7 +35365,7 @@
       </p:sp>
       <p:sp>
         <p:nvSpPr>
-          <p:cNvPr id="68" name="Shape 54"/>
+          <p:cNvPr id="59" name="Shape 48"/>
           <p:cNvSpPr/>
           <p:nvPr/>
         </p:nvSpPr>
@@ -35662,7 +35392,7 @@
       </p:sp>
       <p:sp>
         <p:nvSpPr>
-          <p:cNvPr id="69" name="Text 55"/>
+          <p:cNvPr id="60" name="Text 49"/>
           <p:cNvSpPr/>
           <p:nvPr/>
         </p:nvSpPr>
@@ -35701,7 +35431,7 @@
       </p:sp>
       <p:sp>
         <p:nvSpPr>
-          <p:cNvPr id="70" name="Text 56"/>
+          <p:cNvPr id="61" name="Text 50"/>
           <p:cNvSpPr/>
           <p:nvPr/>
         </p:nvSpPr>
@@ -35799,7 +35529,7 @@
                 <a:ea typeface="Calibri" pitchFamily="34" charset="-122"/>
                 <a:cs typeface="Calibri" pitchFamily="34" charset="-120"/>
               </a:rPr>
-              <a:t>Pemetaan kata yang belum cocok tidak bisa disimpan sebelum diperbaiki</a:t>
+              <a:t>Benda yang belum ada di kosakata dibuatkan kartu kata baru bersuara; bisa dihapus di Kelola kosakata</a:t>
             </a:r>
             <a:endParaRPr lang="en-US" sz="950" dirty="0"/>
           </a:p>
@@ -35828,7 +35558,7 @@
       </p:sp>
       <p:sp>
         <p:nvSpPr>
-          <p:cNvPr id="71" name="Shape 57"/>
+          <p:cNvPr id="62" name="Shape 51"/>
           <p:cNvSpPr/>
           <p:nvPr/>
         </p:nvSpPr>
@@ -35855,7 +35585,7 @@
       </p:sp>
       <p:sp>
         <p:nvSpPr>
-          <p:cNvPr id="72" name="Text 58"/>
+          <p:cNvPr id="63" name="Text 52"/>
           <p:cNvSpPr/>
           <p:nvPr/>
         </p:nvSpPr>
@@ -35894,7 +35624,7 @@
       </p:sp>
       <p:sp>
         <p:nvSpPr>
-          <p:cNvPr id="73" name="Text 59"/>
+          <p:cNvPr id="64" name="Text 53"/>
           <p:cNvSpPr/>
           <p:nvPr/>
         </p:nvSpPr>
@@ -35950,7 +35680,7 @@
                 <a:ea typeface="Calibri" pitchFamily="34" charset="-122"/>
                 <a:cs typeface="Calibri" pitchFamily="34" charset="-120"/>
               </a:rPr>
-              <a:t>Akurasi draf AI belum diukur</a:t>
+              <a:t>Akurasi draf AI belum diukur; kartu kata baru belum bergambar</a:t>
             </a:r>
             <a:endParaRPr lang="en-US" sz="950" dirty="0"/>
           </a:p>

</xml_diff>